<commit_message>
Auto commit on save
</commit_message>
<xml_diff>
--- a/RQs/RQ.pptx
+++ b/RQs/RQ.pptx
@@ -319,7 +319,7 @@
           <a:p>
             <a:fld id="{5BCAD085-E8A6-8845-BD4E-CB4CCA059FC4}" type="datetimeFigureOut">
               <a:rPr lang="en-US" smtClean="0"/>
-              <a:t>9/24/2025</a:t>
+              <a:t>10/2/2025</a:t>
             </a:fld>
             <a:endParaRPr lang="en-US"/>
           </a:p>
@@ -419,6 +419,13 @@
             <a:noFill/>
           </a:ln>
         </p:spPr>
+        <p:txBody>
+          <a:bodyPr/>
+          <a:lstStyle/>
+          <a:p>
+            <a:endParaRPr lang="en-PK"/>
+          </a:p>
+        </p:txBody>
       </p:sp>
       <p:sp>
         <p:nvSpPr>
@@ -651,7 +658,7 @@
           <a:p>
             <a:fld id="{5BCAD085-E8A6-8845-BD4E-CB4CCA059FC4}" type="datetimeFigureOut">
               <a:rPr lang="en-US" smtClean="0"/>
-              <a:t>9/24/2025</a:t>
+              <a:t>10/2/2025</a:t>
             </a:fld>
             <a:endParaRPr lang="en-US"/>
           </a:p>
@@ -1050,7 +1057,7 @@
           <a:p>
             <a:fld id="{5BCAD085-E8A6-8845-BD4E-CB4CCA059FC4}" type="datetimeFigureOut">
               <a:rPr lang="en-US" smtClean="0"/>
-              <a:t>9/24/2025</a:t>
+              <a:t>10/2/2025</a:t>
             </a:fld>
             <a:endParaRPr lang="en-US"/>
           </a:p>
@@ -1384,7 +1391,7 @@
           <a:p>
             <a:fld id="{5BCAD085-E8A6-8845-BD4E-CB4CCA059FC4}" type="datetimeFigureOut">
               <a:rPr lang="en-US" smtClean="0"/>
-              <a:t>9/24/2025</a:t>
+              <a:t>10/2/2025</a:t>
             </a:fld>
             <a:endParaRPr lang="en-US"/>
           </a:p>
@@ -1702,7 +1709,7 @@
           <a:p>
             <a:fld id="{5BCAD085-E8A6-8845-BD4E-CB4CCA059FC4}" type="datetimeFigureOut">
               <a:rPr lang="en-US" smtClean="0"/>
-              <a:t>9/24/2025</a:t>
+              <a:t>10/2/2025</a:t>
             </a:fld>
             <a:endParaRPr lang="en-US"/>
           </a:p>
@@ -2096,7 +2103,7 @@
           <a:p>
             <a:fld id="{5BCAD085-E8A6-8845-BD4E-CB4CCA059FC4}" type="datetimeFigureOut">
               <a:rPr lang="en-US" smtClean="0"/>
-              <a:t>9/24/2025</a:t>
+              <a:t>10/2/2025</a:t>
             </a:fld>
             <a:endParaRPr lang="en-US"/>
           </a:p>
@@ -2351,7 +2358,7 @@
           <a:p>
             <a:fld id="{5BCAD085-E8A6-8845-BD4E-CB4CCA059FC4}" type="datetimeFigureOut">
               <a:rPr lang="en-US" smtClean="0"/>
-              <a:t>9/24/2025</a:t>
+              <a:t>10/2/2025</a:t>
             </a:fld>
             <a:endParaRPr lang="en-US"/>
           </a:p>
@@ -2611,7 +2618,7 @@
           <a:p>
             <a:fld id="{5BCAD085-E8A6-8845-BD4E-CB4CCA059FC4}" type="datetimeFigureOut">
               <a:rPr lang="en-US" smtClean="0"/>
-              <a:t>9/24/2025</a:t>
+              <a:t>10/2/2025</a:t>
             </a:fld>
             <a:endParaRPr lang="en-US"/>
           </a:p>
@@ -2871,7 +2878,7 @@
           <a:p>
             <a:fld id="{5BCAD085-E8A6-8845-BD4E-CB4CCA059FC4}" type="datetimeFigureOut">
               <a:rPr lang="en-US" smtClean="0"/>
-              <a:t>9/24/2025</a:t>
+              <a:t>10/2/2025</a:t>
             </a:fld>
             <a:endParaRPr lang="en-US"/>
           </a:p>
@@ -2975,6 +2982,13 @@
             <a:noFill/>
           </a:ln>
         </p:spPr>
+        <p:txBody>
+          <a:bodyPr/>
+          <a:lstStyle/>
+          <a:p>
+            <a:endParaRPr lang="en-PK"/>
+          </a:p>
+        </p:txBody>
       </p:sp>
       <p:sp>
         <p:nvSpPr>
@@ -3198,7 +3212,7 @@
           <a:p>
             <a:fld id="{5BCAD085-E8A6-8845-BD4E-CB4CCA059FC4}" type="datetimeFigureOut">
               <a:rPr lang="en-US" smtClean="0"/>
-              <a:t>9/24/2025</a:t>
+              <a:t>10/2/2025</a:t>
             </a:fld>
             <a:endParaRPr lang="en-US"/>
           </a:p>
@@ -3519,7 +3533,7 @@
           <a:p>
             <a:fld id="{5BCAD085-E8A6-8845-BD4E-CB4CCA059FC4}" type="datetimeFigureOut">
               <a:rPr lang="en-US" smtClean="0"/>
-              <a:t>9/24/2025</a:t>
+              <a:t>10/2/2025</a:t>
             </a:fld>
             <a:endParaRPr lang="en-US"/>
           </a:p>
@@ -3974,7 +3988,7 @@
           <a:p>
             <a:fld id="{5BCAD085-E8A6-8845-BD4E-CB4CCA059FC4}" type="datetimeFigureOut">
               <a:rPr lang="en-US" smtClean="0"/>
-              <a:t>9/24/2025</a:t>
+              <a:t>10/2/2025</a:t>
             </a:fld>
             <a:endParaRPr lang="en-US"/>
           </a:p>
@@ -4182,7 +4196,7 @@
           <a:p>
             <a:fld id="{5BCAD085-E8A6-8845-BD4E-CB4CCA059FC4}" type="datetimeFigureOut">
               <a:rPr lang="en-US" smtClean="0"/>
-              <a:t>9/24/2025</a:t>
+              <a:t>10/2/2025</a:t>
             </a:fld>
             <a:endParaRPr lang="en-US"/>
           </a:p>
@@ -4357,7 +4371,7 @@
           <a:p>
             <a:fld id="{5BCAD085-E8A6-8845-BD4E-CB4CCA059FC4}" type="datetimeFigureOut">
               <a:rPr lang="en-US" smtClean="0"/>
-              <a:t>9/24/2025</a:t>
+              <a:t>10/2/2025</a:t>
             </a:fld>
             <a:endParaRPr lang="en-US"/>
           </a:p>
@@ -4688,7 +4702,7 @@
           <a:p>
             <a:fld id="{5BCAD085-E8A6-8845-BD4E-CB4CCA059FC4}" type="datetimeFigureOut">
               <a:rPr lang="en-US" smtClean="0"/>
-              <a:t>9/24/2025</a:t>
+              <a:t>10/2/2025</a:t>
             </a:fld>
             <a:endParaRPr lang="en-US"/>
           </a:p>
@@ -5031,7 +5045,7 @@
           <a:p>
             <a:fld id="{5BCAD085-E8A6-8845-BD4E-CB4CCA059FC4}" type="datetimeFigureOut">
               <a:rPr lang="en-US" smtClean="0"/>
-              <a:t>9/24/2025</a:t>
+              <a:t>10/2/2025</a:t>
             </a:fld>
             <a:endParaRPr lang="en-US"/>
           </a:p>
@@ -5273,6 +5287,13 @@
               <a:noFill/>
             </a:ln>
           </p:spPr>
+          <p:txBody>
+            <a:bodyPr/>
+            <a:lstStyle/>
+            <a:p>
+              <a:endParaRPr lang="en-PK"/>
+            </a:p>
+          </p:txBody>
         </p:sp>
         <p:sp>
           <p:nvSpPr>
@@ -5339,6 +5360,13 @@
               <a:noFill/>
             </a:ln>
           </p:spPr>
+          <p:txBody>
+            <a:bodyPr/>
+            <a:lstStyle/>
+            <a:p>
+              <a:endParaRPr lang="en-PK"/>
+            </a:p>
+          </p:txBody>
         </p:sp>
         <p:sp>
           <p:nvSpPr>
@@ -5410,6 +5438,13 @@
               <a:noFill/>
             </a:ln>
           </p:spPr>
+          <p:txBody>
+            <a:bodyPr/>
+            <a:lstStyle/>
+            <a:p>
+              <a:endParaRPr lang="en-PK"/>
+            </a:p>
+          </p:txBody>
         </p:sp>
         <p:sp>
           <p:nvSpPr>
@@ -5461,6 +5496,13 @@
               <a:noFill/>
             </a:ln>
           </p:spPr>
+          <p:txBody>
+            <a:bodyPr/>
+            <a:lstStyle/>
+            <a:p>
+              <a:endParaRPr lang="en-PK"/>
+            </a:p>
+          </p:txBody>
         </p:sp>
         <p:sp>
           <p:nvSpPr>
@@ -5547,6 +5589,13 @@
               <a:noFill/>
             </a:ln>
           </p:spPr>
+          <p:txBody>
+            <a:bodyPr/>
+            <a:lstStyle/>
+            <a:p>
+              <a:endParaRPr lang="en-PK"/>
+            </a:p>
+          </p:txBody>
         </p:sp>
         <p:sp>
           <p:nvSpPr>
@@ -5628,6 +5677,13 @@
               <a:noFill/>
             </a:ln>
           </p:spPr>
+          <p:txBody>
+            <a:bodyPr/>
+            <a:lstStyle/>
+            <a:p>
+              <a:endParaRPr lang="en-PK"/>
+            </a:p>
+          </p:txBody>
         </p:sp>
         <p:sp>
           <p:nvSpPr>
@@ -5689,6 +5745,13 @@
               <a:noFill/>
             </a:ln>
           </p:spPr>
+          <p:txBody>
+            <a:bodyPr/>
+            <a:lstStyle/>
+            <a:p>
+              <a:endParaRPr lang="en-PK"/>
+            </a:p>
+          </p:txBody>
         </p:sp>
         <p:sp>
           <p:nvSpPr>
@@ -5770,6 +5833,13 @@
               <a:noFill/>
             </a:ln>
           </p:spPr>
+          <p:txBody>
+            <a:bodyPr/>
+            <a:lstStyle/>
+            <a:p>
+              <a:endParaRPr lang="en-PK"/>
+            </a:p>
+          </p:txBody>
         </p:sp>
         <p:sp>
           <p:nvSpPr>
@@ -5886,6 +5956,13 @@
               <a:noFill/>
             </a:ln>
           </p:spPr>
+          <p:txBody>
+            <a:bodyPr/>
+            <a:lstStyle/>
+            <a:p>
+              <a:endParaRPr lang="en-PK"/>
+            </a:p>
+          </p:txBody>
         </p:sp>
         <p:sp>
           <p:nvSpPr>
@@ -5937,6 +6014,13 @@
               <a:noFill/>
             </a:ln>
           </p:spPr>
+          <p:txBody>
+            <a:bodyPr/>
+            <a:lstStyle/>
+            <a:p>
+              <a:endParaRPr lang="en-PK"/>
+            </a:p>
+          </p:txBody>
         </p:sp>
         <p:sp>
           <p:nvSpPr>
@@ -5998,6 +6082,13 @@
               <a:noFill/>
             </a:ln>
           </p:spPr>
+          <p:txBody>
+            <a:bodyPr/>
+            <a:lstStyle/>
+            <a:p>
+              <a:endParaRPr lang="en-PK"/>
+            </a:p>
+          </p:txBody>
         </p:sp>
         <p:sp>
           <p:nvSpPr>
@@ -6069,6 +6160,13 @@
               <a:noFill/>
             </a:ln>
           </p:spPr>
+          <p:txBody>
+            <a:bodyPr/>
+            <a:lstStyle/>
+            <a:p>
+              <a:endParaRPr lang="en-PK"/>
+            </a:p>
+          </p:txBody>
         </p:sp>
       </p:grpSp>
       <p:grpSp>
@@ -6188,6 +6286,13 @@
               <a:noFill/>
             </a:ln>
           </p:spPr>
+          <p:txBody>
+            <a:bodyPr/>
+            <a:lstStyle/>
+            <a:p>
+              <a:endParaRPr lang="en-PK"/>
+            </a:p>
+          </p:txBody>
         </p:sp>
         <p:sp>
           <p:nvSpPr>
@@ -6257,6 +6362,13 @@
               <a:noFill/>
             </a:ln>
           </p:spPr>
+          <p:txBody>
+            <a:bodyPr/>
+            <a:lstStyle/>
+            <a:p>
+              <a:endParaRPr lang="en-PK"/>
+            </a:p>
+          </p:txBody>
         </p:sp>
         <p:sp>
           <p:nvSpPr>
@@ -6326,6 +6438,13 @@
               <a:noFill/>
             </a:ln>
           </p:spPr>
+          <p:txBody>
+            <a:bodyPr/>
+            <a:lstStyle/>
+            <a:p>
+              <a:endParaRPr lang="en-PK"/>
+            </a:p>
+          </p:txBody>
         </p:sp>
         <p:sp>
           <p:nvSpPr>
@@ -6410,6 +6529,13 @@
               <a:noFill/>
             </a:ln>
           </p:spPr>
+          <p:txBody>
+            <a:bodyPr/>
+            <a:lstStyle/>
+            <a:p>
+              <a:endParaRPr lang="en-PK"/>
+            </a:p>
+          </p:txBody>
         </p:sp>
         <p:sp>
           <p:nvSpPr>
@@ -6504,6 +6630,13 @@
               <a:noFill/>
             </a:ln>
           </p:spPr>
+          <p:txBody>
+            <a:bodyPr/>
+            <a:lstStyle/>
+            <a:p>
+              <a:endParaRPr lang="en-PK"/>
+            </a:p>
+          </p:txBody>
         </p:sp>
         <p:sp>
           <p:nvSpPr>
@@ -6553,6 +6686,13 @@
               <a:noFill/>
             </a:ln>
           </p:spPr>
+          <p:txBody>
+            <a:bodyPr/>
+            <a:lstStyle/>
+            <a:p>
+              <a:endParaRPr lang="en-PK"/>
+            </a:p>
+          </p:txBody>
         </p:sp>
         <p:sp>
           <p:nvSpPr>
@@ -6617,6 +6757,13 @@
               <a:noFill/>
             </a:ln>
           </p:spPr>
+          <p:txBody>
+            <a:bodyPr/>
+            <a:lstStyle/>
+            <a:p>
+              <a:endParaRPr lang="en-PK"/>
+            </a:p>
+          </p:txBody>
         </p:sp>
         <p:sp>
           <p:nvSpPr>
@@ -6726,6 +6873,13 @@
               <a:noFill/>
             </a:ln>
           </p:spPr>
+          <p:txBody>
+            <a:bodyPr/>
+            <a:lstStyle/>
+            <a:p>
+              <a:endParaRPr lang="en-PK"/>
+            </a:p>
+          </p:txBody>
         </p:sp>
         <p:sp>
           <p:nvSpPr>
@@ -6775,6 +6929,13 @@
               <a:noFill/>
             </a:ln>
           </p:spPr>
+          <p:txBody>
+            <a:bodyPr/>
+            <a:lstStyle/>
+            <a:p>
+              <a:endParaRPr lang="en-PK"/>
+            </a:p>
+          </p:txBody>
         </p:sp>
         <p:sp>
           <p:nvSpPr>
@@ -6844,6 +7005,13 @@
               <a:noFill/>
             </a:ln>
           </p:spPr>
+          <p:txBody>
+            <a:bodyPr/>
+            <a:lstStyle/>
+            <a:p>
+              <a:endParaRPr lang="en-PK"/>
+            </a:p>
+          </p:txBody>
         </p:sp>
         <p:sp>
           <p:nvSpPr>
@@ -6908,6 +7076,13 @@
               <a:noFill/>
             </a:ln>
           </p:spPr>
+          <p:txBody>
+            <a:bodyPr/>
+            <a:lstStyle/>
+            <a:p>
+              <a:endParaRPr lang="en-PK"/>
+            </a:p>
+          </p:txBody>
         </p:sp>
         <p:sp>
           <p:nvSpPr>
@@ -6977,6 +7152,13 @@
               <a:noFill/>
             </a:ln>
           </p:spPr>
+          <p:txBody>
+            <a:bodyPr/>
+            <a:lstStyle/>
+            <a:p>
+              <a:endParaRPr lang="en-PK"/>
+            </a:p>
+          </p:txBody>
         </p:sp>
       </p:grpSp>
       <p:sp>
@@ -7015,6 +7197,13 @@
             <a:schemeClr val="lt1"/>
           </a:fontRef>
         </p:style>
+        <p:txBody>
+          <a:bodyPr/>
+          <a:lstStyle/>
+          <a:p>
+            <a:endParaRPr lang="en-PK"/>
+          </a:p>
+        </p:txBody>
       </p:sp>
       <p:sp>
         <p:nvSpPr>
@@ -7146,7 +7335,7 @@
           <a:p>
             <a:fld id="{5BCAD085-E8A6-8845-BD4E-CB4CCA059FC4}" type="datetimeFigureOut">
               <a:rPr lang="en-US" smtClean="0"/>
-              <a:t>9/24/2025</a:t>
+              <a:t>10/2/2025</a:t>
             </a:fld>
             <a:endParaRPr lang="en-US"/>
           </a:p>
@@ -8949,14 +9138,14 @@
               </a:lnSpc>
             </a:pPr>
             <a:r>
-              <a:rPr lang="en-US" sz="3600">
+              <a:rPr lang="en-US" sz="3600" dirty="0">
                 <a:solidFill>
                   <a:schemeClr val="tx2">
                     <a:lumMod val="75000"/>
                   </a:schemeClr>
                 </a:solidFill>
               </a:rPr>
-              <a:t>Small-Model Multi-Agent Debate to Improve Reasoning of Large Language Models for Source-Code Comprehension</a:t>
+              <a:t>Small-Model Multi-Agent Debate to Improve Reasoning of Language Models for Source-Code Comprehension</a:t>
             </a:r>
           </a:p>
         </p:txBody>
@@ -9164,27 +9353,48 @@
         <p:spPr/>
         <p:txBody>
           <a:bodyPr>
-            <a:normAutofit fontScale="92500" lnSpcReduction="10000"/>
+            <a:normAutofit lnSpcReduction="10000"/>
           </a:bodyPr>
           <a:lstStyle/>
           <a:p>
             <a:r>
+              <a:rPr dirty="0"/>
               <a:t>Prior work on code comprehension evaluation shows that LLMs perform well on factual and surface-level questions but struggle with completeness, clarity, and abstract reasoning.</a:t>
             </a:r>
           </a:p>
           <a:p>
             <a:r>
-              <a:t>Teacher‒student LLM-as-judge with ToM interventions improved evaluation reliability by aligning smaller judge models with larger ones.</a:t>
-            </a:r>
-          </a:p>
-          <a:p>
-            <a:r>
+              <a:rPr dirty="0"/>
+              <a:t>Teacher‒student LLM-as-judge with </a:t>
+            </a:r>
+            <a:r>
+              <a:rPr dirty="0" err="1"/>
+              <a:t>ToM</a:t>
+            </a:r>
+            <a:r>
+              <a:rPr dirty="0"/>
+              <a:t> interventions improved evaluation reliability by aligning smaller judge models with larger ones.</a:t>
+            </a:r>
+          </a:p>
+          <a:p>
+            <a:r>
+              <a:rPr dirty="0"/>
               <a:t>However, this approach remains limited by reliance on a single stronger teacher and high computational cost.</a:t>
             </a:r>
           </a:p>
           <a:p>
-            <a:r>
-              <a:t>Our extension: leverage multi-agent debate among small models (SLMs) to approximate teacher interventions at lower cost while promoting reasoning diversity and error correction.</a:t>
+            <a:pPr lvl="0"/>
+            <a:r>
+              <a:rPr lang="en-US" dirty="0"/>
+              <a:t>Hypothesis: Coordinated debate among **small** models + targeted </a:t>
+            </a:r>
+            <a:r>
+              <a:rPr lang="en-US" dirty="0" err="1"/>
+              <a:t>ToM</a:t>
+            </a:r>
+            <a:r>
+              <a:rPr lang="en-US" dirty="0"/>
+              <a:t> interventions ≈ teacher quality at lower cost.</a:t>
             </a:r>
           </a:p>
         </p:txBody>
@@ -9618,7 +9828,7 @@
             <a:pPr lvl="1"/>
             <a:r>
               <a:rPr dirty="0"/>
-              <a:t>Stratified reporting by question type (What, Why, How, Algorithm, Error, Explanation).</a:t>
+              <a:t>Stratified reporting by question type (Why, How, Algorithm, Error, Explanation).</a:t>
             </a:r>
           </a:p>
           <a:p>

</xml_diff>